<commit_message>
work of first half part of week16
</commit_message>
<xml_diff>
--- a/CRIS_week15.pptx
+++ b/CRIS_week15.pptx
@@ -10,7 +10,6 @@
     <p:sldId id="257" r:id="rId4"/>
     <p:sldId id="262" r:id="rId5"/>
     <p:sldId id="260" r:id="rId6"/>
-    <p:sldId id="261" r:id="rId7"/>
   </p:sldIdLst>
   <p:sldSz cx="12192000" cy="6858000"/>
   <p:notesSz cx="6858000" cy="9144000"/>
@@ -264,7 +263,7 @@
           <a:p>
             <a:fld id="{46C7579C-2082-4292-BDB7-A987B8E5653D}" type="datetimeFigureOut">
               <a:rPr lang="zh-CN" altLang="en-US" smtClean="0"/>
-              <a:t>2026/7/5</a:t>
+              <a:t>2026/7/6</a:t>
             </a:fld>
             <a:endParaRPr lang="zh-CN" altLang="en-US"/>
           </a:p>
@@ -462,7 +461,7 @@
           <a:p>
             <a:fld id="{46C7579C-2082-4292-BDB7-A987B8E5653D}" type="datetimeFigureOut">
               <a:rPr lang="zh-CN" altLang="en-US" smtClean="0"/>
-              <a:t>2026/7/5</a:t>
+              <a:t>2026/7/6</a:t>
             </a:fld>
             <a:endParaRPr lang="zh-CN" altLang="en-US"/>
           </a:p>
@@ -670,7 +669,7 @@
           <a:p>
             <a:fld id="{46C7579C-2082-4292-BDB7-A987B8E5653D}" type="datetimeFigureOut">
               <a:rPr lang="zh-CN" altLang="en-US" smtClean="0"/>
-              <a:t>2026/7/5</a:t>
+              <a:t>2026/7/6</a:t>
             </a:fld>
             <a:endParaRPr lang="zh-CN" altLang="en-US"/>
           </a:p>
@@ -868,7 +867,7 @@
           <a:p>
             <a:fld id="{46C7579C-2082-4292-BDB7-A987B8E5653D}" type="datetimeFigureOut">
               <a:rPr lang="zh-CN" altLang="en-US" smtClean="0"/>
-              <a:t>2026/7/5</a:t>
+              <a:t>2026/7/6</a:t>
             </a:fld>
             <a:endParaRPr lang="zh-CN" altLang="en-US"/>
           </a:p>
@@ -1143,7 +1142,7 @@
           <a:p>
             <a:fld id="{46C7579C-2082-4292-BDB7-A987B8E5653D}" type="datetimeFigureOut">
               <a:rPr lang="zh-CN" altLang="en-US" smtClean="0"/>
-              <a:t>2026/7/5</a:t>
+              <a:t>2026/7/6</a:t>
             </a:fld>
             <a:endParaRPr lang="zh-CN" altLang="en-US"/>
           </a:p>
@@ -1408,7 +1407,7 @@
           <a:p>
             <a:fld id="{46C7579C-2082-4292-BDB7-A987B8E5653D}" type="datetimeFigureOut">
               <a:rPr lang="zh-CN" altLang="en-US" smtClean="0"/>
-              <a:t>2026/7/5</a:t>
+              <a:t>2026/7/6</a:t>
             </a:fld>
             <a:endParaRPr lang="zh-CN" altLang="en-US"/>
           </a:p>
@@ -1820,7 +1819,7 @@
           <a:p>
             <a:fld id="{46C7579C-2082-4292-BDB7-A987B8E5653D}" type="datetimeFigureOut">
               <a:rPr lang="zh-CN" altLang="en-US" smtClean="0"/>
-              <a:t>2026/7/5</a:t>
+              <a:t>2026/7/6</a:t>
             </a:fld>
             <a:endParaRPr lang="zh-CN" altLang="en-US"/>
           </a:p>
@@ -1961,7 +1960,7 @@
           <a:p>
             <a:fld id="{46C7579C-2082-4292-BDB7-A987B8E5653D}" type="datetimeFigureOut">
               <a:rPr lang="zh-CN" altLang="en-US" smtClean="0"/>
-              <a:t>2026/7/5</a:t>
+              <a:t>2026/7/6</a:t>
             </a:fld>
             <a:endParaRPr lang="zh-CN" altLang="en-US"/>
           </a:p>
@@ -2074,7 +2073,7 @@
           <a:p>
             <a:fld id="{46C7579C-2082-4292-BDB7-A987B8E5653D}" type="datetimeFigureOut">
               <a:rPr lang="zh-CN" altLang="en-US" smtClean="0"/>
-              <a:t>2026/7/5</a:t>
+              <a:t>2026/7/6</a:t>
             </a:fld>
             <a:endParaRPr lang="zh-CN" altLang="en-US"/>
           </a:p>
@@ -2385,7 +2384,7 @@
           <a:p>
             <a:fld id="{46C7579C-2082-4292-BDB7-A987B8E5653D}" type="datetimeFigureOut">
               <a:rPr lang="zh-CN" altLang="en-US" smtClean="0"/>
-              <a:t>2026/7/5</a:t>
+              <a:t>2026/7/6</a:t>
             </a:fld>
             <a:endParaRPr lang="zh-CN" altLang="en-US"/>
           </a:p>
@@ -2673,7 +2672,7 @@
           <a:p>
             <a:fld id="{46C7579C-2082-4292-BDB7-A987B8E5653D}" type="datetimeFigureOut">
               <a:rPr lang="zh-CN" altLang="en-US" smtClean="0"/>
-              <a:t>2026/7/5</a:t>
+              <a:t>2026/7/6</a:t>
             </a:fld>
             <a:endParaRPr lang="zh-CN" altLang="en-US"/>
           </a:p>
@@ -2914,7 +2913,7 @@
           <a:p>
             <a:fld id="{46C7579C-2082-4292-BDB7-A987B8E5653D}" type="datetimeFigureOut">
               <a:rPr lang="zh-CN" altLang="en-US" smtClean="0"/>
-              <a:t>2026/7/5</a:t>
+              <a:t>2026/7/6</a:t>
             </a:fld>
             <a:endParaRPr lang="zh-CN" altLang="en-US"/>
           </a:p>
@@ -4382,8 +4381,8 @@
         </p:blipFill>
         <p:spPr>
           <a:xfrm>
-            <a:off x="891910" y="1743982"/>
-            <a:ext cx="4970047" cy="2805512"/>
+            <a:off x="87679" y="-1"/>
+            <a:ext cx="5747668" cy="3244467"/>
           </a:xfrm>
           <a:prstGeom prst="rect">
             <a:avLst/>
@@ -4404,8 +4403,8 @@
         </p:nvSpPr>
         <p:spPr>
           <a:xfrm>
-            <a:off x="6662057" y="1975757"/>
-            <a:ext cx="3739243" cy="369332"/>
+            <a:off x="6585868" y="1443841"/>
+            <a:ext cx="3739243" cy="3970318"/>
           </a:xfrm>
           <a:prstGeom prst="rect">
             <a:avLst/>
@@ -4419,18 +4418,59 @@
           <a:lstStyle/>
           <a:p>
             <a:r>
+              <a:rPr lang="zh-CN" altLang="zh-CN" dirty="0"/>
+              <a:t>binary加噪不会让两者的分布"接近"，而是把两者都随机化，差异反而被噪声本身淹没</a:t>
+            </a:r>
+            <a:endParaRPr lang="en-US" altLang="zh-CN" dirty="0"/>
+          </a:p>
+          <a:p>
+            <a:endParaRPr lang="en-US" altLang="zh-CN" dirty="0"/>
+          </a:p>
+          <a:p>
+            <a:endParaRPr lang="en-US" altLang="zh-CN" dirty="0"/>
+          </a:p>
+          <a:p>
+            <a:r>
+              <a:rPr lang="zh-CN" altLang="zh-CN" b="1" dirty="0"/>
+              <a:t>模型对弱攻击（flip=3%、10%）净化效果为负</a:t>
+            </a:r>
+            <a:r>
+              <a:rPr lang="zh-CN" altLang="zh-CN" dirty="0"/>
+              <a:t>，purification引入的额外误差大于它修复的bit数量。</a:t>
+            </a:r>
+          </a:p>
+          <a:p>
+            <a:r>
+              <a:rPr lang="zh-CN" altLang="zh-CN" b="1" dirty="0"/>
+              <a:t>模型对强攻击（flip=20%、30%）净化有效</a:t>
+            </a:r>
+            <a:r>
+              <a:rPr lang="zh-CN" altLang="zh-CN" dirty="0"/>
+              <a:t>，flip=30%时bit accuracy从0.701提升到0.835，delta=+0.134。</a:t>
+            </a:r>
+            <a:endParaRPr lang="en-US" altLang="zh-CN" dirty="0"/>
+          </a:p>
+          <a:p>
+            <a:r>
               <a:rPr lang="zh-CN" altLang="en-US" dirty="0"/>
-              <a:t>你能</a:t>
-            </a:r>
+              <a:t>目前使用的网络</a:t>
+            </a:r>
+            <a:r>
+              <a:rPr lang="zh-CN" altLang="zh-CN" dirty="0"/>
+              <a:t>MLP容量不足，无法做到精确的局部修复</a:t>
+            </a:r>
+          </a:p>
+          <a:p>
+            <a:endParaRPr lang="zh-CN" altLang="en-US" dirty="0"/>
           </a:p>
         </p:txBody>
       </p:sp>
       <p:pic>
         <p:nvPicPr>
-          <p:cNvPr id="10" name="图片 9">
-            <a:extLst>
-              <a:ext uri="{FF2B5EF4-FFF2-40B4-BE49-F238E27FC236}">
-                <a16:creationId xmlns:a16="http://schemas.microsoft.com/office/drawing/2014/main" id="{4B9D2E74-026A-5601-2482-202D930BA4C7}"/>
+          <p:cNvPr id="4" name="图片 3">
+            <a:extLst>
+              <a:ext uri="{FF2B5EF4-FFF2-40B4-BE49-F238E27FC236}">
+                <a16:creationId xmlns:a16="http://schemas.microsoft.com/office/drawing/2014/main" id="{C575FAA5-4E46-93F7-B6D8-A0AA04218B95}"/>
               </a:ext>
             </a:extLst>
           </p:cNvPr>
@@ -4440,21 +4480,15 @@
           <p:nvPr/>
         </p:nvPicPr>
         <p:blipFill>
-          <a:blip r:embed="rId3">
-            <a:extLst>
-              <a:ext uri="{28A0092B-C50C-407E-A947-70E740481C1C}">
-                <a14:useLocalDpi xmlns:a14="http://schemas.microsoft.com/office/drawing/2010/main" val="0"/>
-              </a:ext>
-            </a:extLst>
-          </a:blip>
+          <a:blip r:embed="rId3"/>
           <a:stretch>
             <a:fillRect/>
           </a:stretch>
         </p:blipFill>
         <p:spPr>
           <a:xfrm>
-            <a:off x="7065131" y="3010579"/>
-            <a:ext cx="4370312" cy="2731445"/>
+            <a:off x="353849" y="3342433"/>
+            <a:ext cx="5371206" cy="2984003"/>
           </a:xfrm>
           <a:prstGeom prst="rect">
             <a:avLst/>
@@ -4514,186 +4548,46 @@
           </a:bodyPr>
           <a:lstStyle/>
           <a:p>
-            <a:r>
-              <a:rPr lang="zh-CN" altLang="zh-CN" sz="3200" dirty="0"/>
-              <a:t>Masked Bernoulli Diffusion</a:t>
-            </a:r>
             <a:endParaRPr lang="zh-CN" altLang="en-US" sz="3200" dirty="0"/>
           </a:p>
         </p:txBody>
       </p:sp>
-      <p:sp>
-        <p:nvSpPr>
-          <p:cNvPr id="3" name="内容占位符 2">
-            <a:extLst>
-              <a:ext uri="{FF2B5EF4-FFF2-40B4-BE49-F238E27FC236}">
-                <a16:creationId xmlns:a16="http://schemas.microsoft.com/office/drawing/2014/main" id="{1C29D5B6-7163-30E0-7478-C8A8F1426053}"/>
-              </a:ext>
-            </a:extLst>
-          </p:cNvPr>
-          <p:cNvSpPr>
-            <a:spLocks noGrp="1"/>
-          </p:cNvSpPr>
+      <p:pic>
+        <p:nvPicPr>
+          <p:cNvPr id="5" name="内容占位符 4">
+            <a:extLst>
+              <a:ext uri="{FF2B5EF4-FFF2-40B4-BE49-F238E27FC236}">
+                <a16:creationId xmlns:a16="http://schemas.microsoft.com/office/drawing/2014/main" id="{0411572A-DE0B-B51C-D32E-CD5E23564BF1}"/>
+              </a:ext>
+            </a:extLst>
+          </p:cNvPr>
+          <p:cNvPicPr>
+            <a:picLocks noGrp="1" noChangeAspect="1"/>
+          </p:cNvPicPr>
           <p:nvPr>
             <p:ph idx="1"/>
           </p:nvPr>
-        </p:nvSpPr>
-        <p:spPr/>
-        <p:txBody>
-          <a:bodyPr/>
-          <a:lstStyle/>
-          <a:p>
-            <a:r>
-              <a:rPr lang="zh-CN" altLang="en-US" sz="2400" dirty="0"/>
-              <a:t>结构：</a:t>
-            </a:r>
-            <a:r>
-              <a:rPr lang="zh-CN" altLang="zh-CN" sz="2400" dirty="0"/>
-              <a:t>先用autoencoder把图像压缩到binary latent表示，再在这个binary latent空间上用Bernoulli噪声schedule训练diffusion模型，用去噪过程中bit翻转概率高的位置来识别异常区域。</a:t>
-            </a:r>
-            <a:endParaRPr lang="en-US" altLang="zh-CN" sz="2400" dirty="0"/>
-          </a:p>
-          <a:p>
-            <a:r>
-              <a:rPr lang="zh-CN" altLang="zh-CN" sz="2400" dirty="0"/>
-              <a:t>MICCAI</a:t>
-            </a:r>
-            <a:r>
-              <a:rPr lang="zh-CN" altLang="en-US" sz="2400" dirty="0"/>
-              <a:t>：</a:t>
-            </a:r>
-            <a:r>
-              <a:rPr lang="zh-CN" altLang="zh-CN" sz="2400" b="1" dirty="0"/>
-              <a:t>无监督异常检测</a:t>
-            </a:r>
-            <a:r>
-              <a:rPr lang="zh-CN" altLang="zh-CN" sz="2400" dirty="0"/>
-              <a:t>，异常是自然发生的病变，目标是定位哪些区域异常</a:t>
-            </a:r>
-            <a:r>
-              <a:rPr lang="zh-CN" altLang="en-US" sz="2400" dirty="0"/>
-              <a:t>，</a:t>
-            </a:r>
-            <a:r>
-              <a:rPr lang="zh-CN" altLang="zh-CN" sz="2400" dirty="0"/>
-              <a:t>不需要修复图像。</a:t>
-            </a:r>
-          </a:p>
-          <a:p>
-            <a:r>
-              <a:rPr lang="zh-CN" altLang="en-US" sz="2400" b="1" dirty="0"/>
-              <a:t>我们的</a:t>
-            </a:r>
-            <a:r>
-              <a:rPr lang="zh-CN" altLang="zh-CN" sz="2400" b="1" dirty="0"/>
-              <a:t>对抗样本净化</a:t>
-            </a:r>
-            <a:r>
-              <a:rPr lang="zh-CN" altLang="zh-CN" sz="2400" dirty="0"/>
-              <a:t>，异常是人为注入的对抗扰动，目标是恢复干净图像送给分类器。</a:t>
-            </a:r>
-            <a:r>
-              <a:rPr lang="zh-CN" altLang="en-US" sz="2400" dirty="0"/>
-              <a:t>我们</a:t>
-            </a:r>
-            <a:r>
-              <a:rPr lang="zh-CN" altLang="zh-CN" sz="2400" dirty="0"/>
-              <a:t>需要的不只是检测哪些bit被扰动了，还需要把它们恢复回正确的值。这是一个更强的任务要求。</a:t>
-            </a:r>
-          </a:p>
-          <a:p>
-            <a:endParaRPr lang="zh-CN" altLang="en-US" dirty="0"/>
-          </a:p>
-        </p:txBody>
-      </p:sp>
+        </p:nvPicPr>
+        <p:blipFill>
+          <a:blip r:embed="rId2"/>
+          <a:stretch>
+            <a:fillRect/>
+          </a:stretch>
+        </p:blipFill>
+        <p:spPr>
+          <a:xfrm>
+            <a:off x="1636430" y="2029436"/>
+            <a:ext cx="8350359" cy="4602560"/>
+          </a:xfrm>
+          <a:prstGeom prst="rect">
+            <a:avLst/>
+          </a:prstGeom>
+        </p:spPr>
+      </p:pic>
     </p:spTree>
     <p:extLst>
       <p:ext uri="{BB962C8B-B14F-4D97-AF65-F5344CB8AC3E}">
         <p14:creationId xmlns:p14="http://schemas.microsoft.com/office/powerpoint/2010/main" val="542621025"/>
-      </p:ext>
-    </p:extLst>
-  </p:cSld>
-  <p:clrMapOvr>
-    <a:masterClrMapping/>
-  </p:clrMapOvr>
-</p:sld>
-</file>
-
-<file path=ppt/slides/slide6.xml><?xml version="1.0" encoding="utf-8"?>
-<p:sld xmlns:a="http://schemas.openxmlformats.org/drawingml/2006/main" xmlns:r="http://schemas.openxmlformats.org/officeDocument/2006/relationships" xmlns:p="http://schemas.openxmlformats.org/presentationml/2006/main">
-  <p:cSld>
-    <p:spTree>
-      <p:nvGrpSpPr>
-        <p:cNvPr id="1" name=""/>
-        <p:cNvGrpSpPr/>
-        <p:nvPr/>
-      </p:nvGrpSpPr>
-      <p:grpSpPr>
-        <a:xfrm>
-          <a:off x="0" y="0"/>
-          <a:ext cx="0" cy="0"/>
-          <a:chOff x="0" y="0"/>
-          <a:chExt cx="0" cy="0"/>
-        </a:xfrm>
-      </p:grpSpPr>
-      <p:sp>
-        <p:nvSpPr>
-          <p:cNvPr id="2" name="标题 1">
-            <a:extLst>
-              <a:ext uri="{FF2B5EF4-FFF2-40B4-BE49-F238E27FC236}">
-                <a16:creationId xmlns:a16="http://schemas.microsoft.com/office/drawing/2014/main" id="{F48C4260-C284-1C0B-31CD-1578AE5573AD}"/>
-              </a:ext>
-            </a:extLst>
-          </p:cNvPr>
-          <p:cNvSpPr>
-            <a:spLocks noGrp="1"/>
-          </p:cNvSpPr>
-          <p:nvPr>
-            <p:ph type="title"/>
-          </p:nvPr>
-        </p:nvSpPr>
-        <p:spPr/>
-        <p:txBody>
-          <a:bodyPr/>
-          <a:lstStyle/>
-          <a:p>
-            <a:endParaRPr lang="zh-CN" altLang="en-US"/>
-          </a:p>
-        </p:txBody>
-      </p:sp>
-      <p:sp>
-        <p:nvSpPr>
-          <p:cNvPr id="3" name="内容占位符 2">
-            <a:extLst>
-              <a:ext uri="{FF2B5EF4-FFF2-40B4-BE49-F238E27FC236}">
-                <a16:creationId xmlns:a16="http://schemas.microsoft.com/office/drawing/2014/main" id="{5EE07A05-41BB-8333-86AF-F2B869AE3588}"/>
-              </a:ext>
-            </a:extLst>
-          </p:cNvPr>
-          <p:cNvSpPr>
-            <a:spLocks noGrp="1"/>
-          </p:cNvSpPr>
-          <p:nvPr>
-            <p:ph idx="1"/>
-          </p:nvPr>
-        </p:nvSpPr>
-        <p:spPr/>
-        <p:txBody>
-          <a:bodyPr/>
-          <a:lstStyle/>
-          <a:p>
-            <a:r>
-              <a:rPr lang="zh-CN" altLang="zh-CN" dirty="0"/>
-              <a:t>MICCAI论文提出的masking算法，基于这些翻转概率提出了一种masking算法来改善异常检测分数。可以把类似的masking机制引入反向去噪过程，优先修复高翻转概率的bit，低翻转概率的bit保持不变，从而在净化对抗扰动的同时更好地保留语义信息</a:t>
-            </a:r>
-            <a:endParaRPr lang="zh-CN" altLang="en-US" dirty="0"/>
-          </a:p>
-        </p:txBody>
-      </p:sp>
-    </p:spTree>
-    <p:extLst>
-      <p:ext uri="{BB962C8B-B14F-4D97-AF65-F5344CB8AC3E}">
-        <p14:creationId xmlns:p14="http://schemas.microsoft.com/office/powerpoint/2010/main" val="400638573"/>
       </p:ext>
     </p:extLst>
   </p:cSld>

</xml_diff>